<commit_message>
patched a problem with the slides
</commit_message>
<xml_diff>
--- a/presentation/Pricing Modeling Presentation.pptx
+++ b/presentation/Pricing Modeling Presentation.pptx
@@ -5,19 +5,18 @@
     <p:sldMasterId id="2147483678" r:id="rId1"/>
   </p:sldMasterIdLst>
   <p:notesMasterIdLst>
-    <p:notesMasterId r:id="rId12"/>
+    <p:notesMasterId r:id="rId11"/>
   </p:notesMasterIdLst>
   <p:sldIdLst>
     <p:sldId id="256" r:id="rId2"/>
-    <p:sldId id="258" r:id="rId3"/>
-    <p:sldId id="259" r:id="rId4"/>
-    <p:sldId id="260" r:id="rId5"/>
-    <p:sldId id="261" r:id="rId6"/>
-    <p:sldId id="262" r:id="rId7"/>
-    <p:sldId id="264" r:id="rId8"/>
-    <p:sldId id="265" r:id="rId9"/>
-    <p:sldId id="266" r:id="rId10"/>
-    <p:sldId id="267" r:id="rId11"/>
+    <p:sldId id="259" r:id="rId3"/>
+    <p:sldId id="260" r:id="rId4"/>
+    <p:sldId id="261" r:id="rId5"/>
+    <p:sldId id="262" r:id="rId6"/>
+    <p:sldId id="264" r:id="rId7"/>
+    <p:sldId id="265" r:id="rId8"/>
+    <p:sldId id="266" r:id="rId9"/>
+    <p:sldId id="267" r:id="rId10"/>
   </p:sldIdLst>
   <p:sldSz cx="12192000" cy="6858000"/>
   <p:notesSz cx="6858000" cy="9144000"/>
@@ -134,20 +133,6 @@
     </p:extLst>
   </p:cmAuthor>
 </p:cmAuthorLst>
-</file>
-
-<file path=ppt/comments/comment1.xml><?xml version="1.0" encoding="utf-8"?>
-<p:cmLst xmlns:a="http://schemas.openxmlformats.org/drawingml/2006/main" xmlns:r="http://schemas.openxmlformats.org/officeDocument/2006/relationships" xmlns:p="http://schemas.openxmlformats.org/presentationml/2006/main">
-  <p:cm authorId="1" dt="2025-11-13T14:38:56.331" idx="3">
-    <p:pos x="5588" y="1716"/>
-    <p:text>Animate this answer</p:text>
-    <p:extLst>
-      <p:ext uri="{C676402C-5697-4E1C-873F-D02D1690AC5C}">
-        <p15:threadingInfo xmlns:p15="http://schemas.microsoft.com/office/powerpoint/2012/main" timeZoneBias="300"/>
-      </p:ext>
-    </p:extLst>
-  </p:cm>
-</p:cmLst>
 </file>
 
 <file path=ppt/diagrams/colors1.xml><?xml version="1.0" encoding="utf-8"?>
@@ -9985,7 +9970,7 @@
           <a:p>
             <a:fld id="{38707DB8-AF67-47A2-AE0C-6B7A0D7AFCA7}" type="slidenum">
               <a:rPr lang="en-US" smtClean="0"/>
-              <a:t>4</a:t>
+              <a:t>3</a:t>
             </a:fld>
             <a:endParaRPr lang="en-US"/>
           </a:p>
@@ -17637,180 +17622,7 @@
 </p:sld>
 </file>
 
-<file path=ppt/slides/slide10.xml><?xml version="1.0" encoding="utf-8"?>
-<p:sld xmlns:a="http://schemas.openxmlformats.org/drawingml/2006/main" xmlns:r="http://schemas.openxmlformats.org/officeDocument/2006/relationships" xmlns:p="http://schemas.openxmlformats.org/presentationml/2006/main">
-  <p:cSld>
-    <p:spTree>
-      <p:nvGrpSpPr>
-        <p:cNvPr id="1" name=""/>
-        <p:cNvGrpSpPr/>
-        <p:nvPr/>
-      </p:nvGrpSpPr>
-      <p:grpSpPr>
-        <a:xfrm>
-          <a:off x="0" y="0"/>
-          <a:ext cx="0" cy="0"/>
-          <a:chOff x="0" y="0"/>
-          <a:chExt cx="0" cy="0"/>
-        </a:xfrm>
-      </p:grpSpPr>
-      <p:sp>
-        <p:nvSpPr>
-          <p:cNvPr id="2" name="Title 1">
-            <a:extLst>
-              <a:ext uri="{FF2B5EF4-FFF2-40B4-BE49-F238E27FC236}">
-                <a16:creationId xmlns:a16="http://schemas.microsoft.com/office/drawing/2014/main" id="{D6927622-DEAD-8490-1E2A-1F1E9114D115}"/>
-              </a:ext>
-            </a:extLst>
-          </p:cNvPr>
-          <p:cNvSpPr>
-            <a:spLocks noGrp="1"/>
-          </p:cNvSpPr>
-          <p:nvPr>
-            <p:ph type="title"/>
-          </p:nvPr>
-        </p:nvSpPr>
-        <p:spPr/>
-        <p:txBody>
-          <a:bodyPr/>
-          <a:lstStyle/>
-          <a:p>
-            <a:r>
-              <a:rPr lang="en-US" dirty="0"/>
-              <a:t>Appendix</a:t>
-            </a:r>
-          </a:p>
-        </p:txBody>
-      </p:sp>
-      <p:sp>
-        <p:nvSpPr>
-          <p:cNvPr id="3" name="Content Placeholder 2">
-            <a:extLst>
-              <a:ext uri="{FF2B5EF4-FFF2-40B4-BE49-F238E27FC236}">
-                <a16:creationId xmlns:a16="http://schemas.microsoft.com/office/drawing/2014/main" id="{2C74498D-FC4D-9C1F-5C94-F084D0F362AD}"/>
-              </a:ext>
-            </a:extLst>
-          </p:cNvPr>
-          <p:cNvSpPr>
-            <a:spLocks noGrp="1"/>
-          </p:cNvSpPr>
-          <p:nvPr>
-            <p:ph idx="1"/>
-          </p:nvPr>
-        </p:nvSpPr>
-        <p:spPr/>
-        <p:txBody>
-          <a:bodyPr/>
-          <a:lstStyle/>
-          <a:p>
-            <a:r>
-              <a:rPr lang="en-US" dirty="0">
-                <a:hlinkClick r:id="rId2"/>
-              </a:rPr>
-              <a:t>Swiss Actuaries Actuarial Data Science Tutorials</a:t>
-            </a:r>
-            <a:endParaRPr lang="en-US" dirty="0"/>
-          </a:p>
-          <a:p>
-            <a:pPr lvl="1"/>
-            <a:r>
-              <a:rPr lang="en-US" dirty="0"/>
-              <a:t>We did Case Study 1 tonight</a:t>
-            </a:r>
-          </a:p>
-          <a:p>
-            <a:pPr lvl="1"/>
-            <a:r>
-              <a:rPr lang="en-US" dirty="0"/>
-              <a:t>There are currently 16 case studies that explore actuarial data science topics and techniques</a:t>
-            </a:r>
-          </a:p>
-          <a:p>
-            <a:pPr lvl="1"/>
-            <a:r>
-              <a:rPr lang="en-US" dirty="0"/>
-              <a:t>There is also a fantastic Data Sets log that can help you find datasets for your own projects</a:t>
-            </a:r>
-          </a:p>
-        </p:txBody>
-      </p:sp>
-    </p:spTree>
-    <p:extLst>
-      <p:ext uri="{BB962C8B-B14F-4D97-AF65-F5344CB8AC3E}">
-        <p14:creationId xmlns:p14="http://schemas.microsoft.com/office/powerpoint/2010/main" val="2436515003"/>
-      </p:ext>
-    </p:extLst>
-  </p:cSld>
-  <p:clrMapOvr>
-    <a:masterClrMapping/>
-  </p:clrMapOvr>
-</p:sld>
-</file>
-
 <file path=ppt/slides/slide2.xml><?xml version="1.0" encoding="utf-8"?>
-<p:sld xmlns:a="http://schemas.openxmlformats.org/drawingml/2006/main" xmlns:r="http://schemas.openxmlformats.org/officeDocument/2006/relationships" xmlns:p="http://schemas.openxmlformats.org/presentationml/2006/main">
-  <p:cSld>
-    <p:spTree>
-      <p:nvGrpSpPr>
-        <p:cNvPr id="1" name=""/>
-        <p:cNvGrpSpPr/>
-        <p:nvPr/>
-      </p:nvGrpSpPr>
-      <p:grpSpPr>
-        <a:xfrm>
-          <a:off x="0" y="0"/>
-          <a:ext cx="0" cy="0"/>
-          <a:chOff x="0" y="0"/>
-          <a:chExt cx="0" cy="0"/>
-        </a:xfrm>
-      </p:grpSpPr>
-      <p:sp>
-        <p:nvSpPr>
-          <p:cNvPr id="11" name="Title 10">
-            <a:extLst>
-              <a:ext uri="{FF2B5EF4-FFF2-40B4-BE49-F238E27FC236}">
-                <a16:creationId xmlns:a16="http://schemas.microsoft.com/office/drawing/2014/main" id="{0C8E1636-228B-6F94-04AA-12F3FE06BA70}"/>
-              </a:ext>
-            </a:extLst>
-          </p:cNvPr>
-          <p:cNvSpPr>
-            <a:spLocks noGrp="1"/>
-          </p:cNvSpPr>
-          <p:nvPr>
-            <p:ph type="title"/>
-          </p:nvPr>
-        </p:nvSpPr>
-        <p:spPr>
-          <a:xfrm>
-            <a:off x="1773049" y="612287"/>
-            <a:ext cx="8911687" cy="1280890"/>
-          </a:xfrm>
-        </p:spPr>
-        <p:txBody>
-          <a:bodyPr/>
-          <a:lstStyle/>
-          <a:p>
-            <a:r>
-              <a:rPr lang="en-US" dirty="0"/>
-              <a:t>About Me</a:t>
-            </a:r>
-          </a:p>
-        </p:txBody>
-      </p:sp>
-    </p:spTree>
-    <p:extLst>
-      <p:ext uri="{BB962C8B-B14F-4D97-AF65-F5344CB8AC3E}">
-        <p14:creationId xmlns:p14="http://schemas.microsoft.com/office/powerpoint/2010/main" val="3650606941"/>
-      </p:ext>
-    </p:extLst>
-  </p:cSld>
-  <p:clrMapOvr>
-    <a:masterClrMapping/>
-  </p:clrMapOvr>
-</p:sld>
-</file>
-
-<file path=ppt/slides/slide3.xml><?xml version="1.0" encoding="utf-8"?>
 <p:sld xmlns:a="http://schemas.openxmlformats.org/drawingml/2006/main" xmlns:r="http://schemas.openxmlformats.org/officeDocument/2006/relationships" xmlns:p="http://schemas.openxmlformats.org/presentationml/2006/main">
   <p:cSld>
     <p:spTree>
@@ -17914,7 +17726,7 @@
 </p:sld>
 </file>
 
-<file path=ppt/slides/slide4.xml><?xml version="1.0" encoding="utf-8"?>
+<file path=ppt/slides/slide3.xml><?xml version="1.0" encoding="utf-8"?>
 <p:sld xmlns:a="http://schemas.openxmlformats.org/drawingml/2006/main" xmlns:r="http://schemas.openxmlformats.org/officeDocument/2006/relationships" xmlns:p="http://schemas.openxmlformats.org/presentationml/2006/main">
   <p:cSld>
     <p:spTree>
@@ -18130,7 +17942,7 @@
 </p:sld>
 </file>
 
-<file path=ppt/slides/slide5.xml><?xml version="1.0" encoding="utf-8"?>
+<file path=ppt/slides/slide4.xml><?xml version="1.0" encoding="utf-8"?>
 <p:sld xmlns:a="http://schemas.openxmlformats.org/drawingml/2006/main" xmlns:r="http://schemas.openxmlformats.org/officeDocument/2006/relationships" xmlns:p="http://schemas.openxmlformats.org/presentationml/2006/main">
   <p:cSld>
     <p:spTree>
@@ -18361,7 +18173,7 @@
 </p:sld>
 </file>
 
-<file path=ppt/slides/slide6.xml><?xml version="1.0" encoding="utf-8"?>
+<file path=ppt/slides/slide5.xml><?xml version="1.0" encoding="utf-8"?>
 <p:sld xmlns:a="http://schemas.openxmlformats.org/drawingml/2006/main" xmlns:r="http://schemas.openxmlformats.org/officeDocument/2006/relationships" xmlns:p="http://schemas.openxmlformats.org/presentationml/2006/main">
   <p:cSld>
     <p:spTree>
@@ -18642,7 +18454,7 @@
 </p:sld>
 </file>
 
-<file path=ppt/slides/slide7.xml><?xml version="1.0" encoding="utf-8"?>
+<file path=ppt/slides/slide6.xml><?xml version="1.0" encoding="utf-8"?>
 <p:sld xmlns:a="http://schemas.openxmlformats.org/drawingml/2006/main" xmlns:r="http://schemas.openxmlformats.org/officeDocument/2006/relationships" xmlns:p="http://schemas.openxmlformats.org/presentationml/2006/main">
   <p:cSld>
     <p:spTree>
@@ -18706,19 +18518,26 @@
         <p:spPr/>
         <p:txBody>
           <a:bodyPr>
-            <a:normAutofit lnSpcReduction="10000"/>
+            <a:normAutofit fontScale="92500" lnSpcReduction="20000"/>
           </a:bodyPr>
           <a:lstStyle/>
           <a:p>
             <a:r>
               <a:rPr lang="en-US" dirty="0"/>
-              <a:t>Say we estimate our future Losses to be $2mil, our future Expenses to be $1mil and our target CR to be 95%. </a:t>
+              <a:t>Say we estimate our future Losses to be $650K, our future Expenses to be $300K and our target CR to be 95%. </a:t>
             </a:r>
           </a:p>
           <a:p>
             <a:r>
               <a:rPr lang="en-US" dirty="0"/>
-              <a:t>Question: What should our Premiums be? $2.85 million</a:t>
+              <a:t>Question: What should our Premiums be? </a:t>
+            </a:r>
+          </a:p>
+          <a:p>
+            <a:pPr lvl="1"/>
+            <a:r>
+              <a:rPr lang="en-US" dirty="0"/>
+              <a:t>~$1 million</a:t>
             </a:r>
           </a:p>
           <a:p>
@@ -18795,10 +18614,89 @@
   <p:clrMapOvr>
     <a:masterClrMapping/>
   </p:clrMapOvr>
+  <p:timing>
+    <p:tnLst>
+      <p:par>
+        <p:cTn id="1" dur="indefinite" restart="never" nodeType="tmRoot">
+          <p:childTnLst>
+            <p:seq concurrent="1" nextAc="seek">
+              <p:cTn id="2" dur="indefinite" nodeType="mainSeq">
+                <p:childTnLst>
+                  <p:par>
+                    <p:cTn id="3" fill="hold">
+                      <p:stCondLst>
+                        <p:cond delay="indefinite"/>
+                      </p:stCondLst>
+                      <p:childTnLst>
+                        <p:par>
+                          <p:cTn id="4" fill="hold">
+                            <p:stCondLst>
+                              <p:cond delay="0"/>
+                            </p:stCondLst>
+                            <p:childTnLst>
+                              <p:par>
+                                <p:cTn id="5" presetID="1" presetClass="entr" presetSubtype="0" fill="hold" nodeType="clickEffect">
+                                  <p:stCondLst>
+                                    <p:cond delay="0"/>
+                                  </p:stCondLst>
+                                  <p:childTnLst>
+                                    <p:set>
+                                      <p:cBhvr>
+                                        <p:cTn id="6" dur="1" fill="hold">
+                                          <p:stCondLst>
+                                            <p:cond delay="0"/>
+                                          </p:stCondLst>
+                                        </p:cTn>
+                                        <p:tgtEl>
+                                          <p:spTgt spid="3">
+                                            <p:txEl>
+                                              <p:pRg st="2" end="2"/>
+                                            </p:txEl>
+                                          </p:spTgt>
+                                        </p:tgtEl>
+                                        <p:attrNameLst>
+                                          <p:attrName>style.visibility</p:attrName>
+                                        </p:attrNameLst>
+                                      </p:cBhvr>
+                                      <p:to>
+                                        <p:strVal val="visible"/>
+                                      </p:to>
+                                    </p:set>
+                                  </p:childTnLst>
+                                </p:cTn>
+                              </p:par>
+                            </p:childTnLst>
+                          </p:cTn>
+                        </p:par>
+                      </p:childTnLst>
+                    </p:cTn>
+                  </p:par>
+                </p:childTnLst>
+              </p:cTn>
+              <p:prevCondLst>
+                <p:cond evt="onPrev" delay="0">
+                  <p:tgtEl>
+                    <p:sldTgt/>
+                  </p:tgtEl>
+                </p:cond>
+              </p:prevCondLst>
+              <p:nextCondLst>
+                <p:cond evt="onNext" delay="0">
+                  <p:tgtEl>
+                    <p:sldTgt/>
+                  </p:tgtEl>
+                </p:cond>
+              </p:nextCondLst>
+            </p:seq>
+          </p:childTnLst>
+        </p:cTn>
+      </p:par>
+    </p:tnLst>
+  </p:timing>
 </p:sld>
 </file>
 
-<file path=ppt/slides/slide8.xml><?xml version="1.0" encoding="utf-8"?>
+<file path=ppt/slides/slide7.xml><?xml version="1.0" encoding="utf-8"?>
 <p:sld xmlns:a="http://schemas.openxmlformats.org/drawingml/2006/main" xmlns:r="http://schemas.openxmlformats.org/officeDocument/2006/relationships" xmlns:p="http://schemas.openxmlformats.org/presentationml/2006/main">
   <p:cSld>
     <p:spTree>
@@ -19187,7 +19085,7 @@
 </p:sld>
 </file>
 
-<file path=ppt/slides/slide9.xml><?xml version="1.0" encoding="utf-8"?>
+<file path=ppt/slides/slide8.xml><?xml version="1.0" encoding="utf-8"?>
 <p:sld xmlns:a="http://schemas.openxmlformats.org/drawingml/2006/main" xmlns:r="http://schemas.openxmlformats.org/officeDocument/2006/relationships" xmlns:p="http://schemas.openxmlformats.org/presentationml/2006/main">
   <p:cSld>
     <p:spTree>
@@ -19264,6 +19162,116 @@
     <p:extLst>
       <p:ext uri="{BB962C8B-B14F-4D97-AF65-F5344CB8AC3E}">
         <p14:creationId xmlns:p14="http://schemas.microsoft.com/office/powerpoint/2010/main" val="8529118"/>
+      </p:ext>
+    </p:extLst>
+  </p:cSld>
+  <p:clrMapOvr>
+    <a:masterClrMapping/>
+  </p:clrMapOvr>
+</p:sld>
+</file>
+
+<file path=ppt/slides/slide9.xml><?xml version="1.0" encoding="utf-8"?>
+<p:sld xmlns:a="http://schemas.openxmlformats.org/drawingml/2006/main" xmlns:r="http://schemas.openxmlformats.org/officeDocument/2006/relationships" xmlns:p="http://schemas.openxmlformats.org/presentationml/2006/main">
+  <p:cSld>
+    <p:spTree>
+      <p:nvGrpSpPr>
+        <p:cNvPr id="1" name=""/>
+        <p:cNvGrpSpPr/>
+        <p:nvPr/>
+      </p:nvGrpSpPr>
+      <p:grpSpPr>
+        <a:xfrm>
+          <a:off x="0" y="0"/>
+          <a:ext cx="0" cy="0"/>
+          <a:chOff x="0" y="0"/>
+          <a:chExt cx="0" cy="0"/>
+        </a:xfrm>
+      </p:grpSpPr>
+      <p:sp>
+        <p:nvSpPr>
+          <p:cNvPr id="2" name="Title 1">
+            <a:extLst>
+              <a:ext uri="{FF2B5EF4-FFF2-40B4-BE49-F238E27FC236}">
+                <a16:creationId xmlns:a16="http://schemas.microsoft.com/office/drawing/2014/main" id="{D6927622-DEAD-8490-1E2A-1F1E9114D115}"/>
+              </a:ext>
+            </a:extLst>
+          </p:cNvPr>
+          <p:cNvSpPr>
+            <a:spLocks noGrp="1"/>
+          </p:cNvSpPr>
+          <p:nvPr>
+            <p:ph type="title"/>
+          </p:nvPr>
+        </p:nvSpPr>
+        <p:spPr/>
+        <p:txBody>
+          <a:bodyPr/>
+          <a:lstStyle/>
+          <a:p>
+            <a:r>
+              <a:rPr lang="en-US" dirty="0"/>
+              <a:t>Appendix</a:t>
+            </a:r>
+          </a:p>
+        </p:txBody>
+      </p:sp>
+      <p:sp>
+        <p:nvSpPr>
+          <p:cNvPr id="3" name="Content Placeholder 2">
+            <a:extLst>
+              <a:ext uri="{FF2B5EF4-FFF2-40B4-BE49-F238E27FC236}">
+                <a16:creationId xmlns:a16="http://schemas.microsoft.com/office/drawing/2014/main" id="{2C74498D-FC4D-9C1F-5C94-F084D0F362AD}"/>
+              </a:ext>
+            </a:extLst>
+          </p:cNvPr>
+          <p:cNvSpPr>
+            <a:spLocks noGrp="1"/>
+          </p:cNvSpPr>
+          <p:nvPr>
+            <p:ph idx="1"/>
+          </p:nvPr>
+        </p:nvSpPr>
+        <p:spPr/>
+        <p:txBody>
+          <a:bodyPr/>
+          <a:lstStyle/>
+          <a:p>
+            <a:r>
+              <a:rPr lang="en-US" dirty="0">
+                <a:hlinkClick r:id="rId2"/>
+              </a:rPr>
+              <a:t>Swiss Actuaries Actuarial Data Science Tutorials</a:t>
+            </a:r>
+            <a:endParaRPr lang="en-US" dirty="0"/>
+          </a:p>
+          <a:p>
+            <a:pPr lvl="1"/>
+            <a:r>
+              <a:rPr lang="en-US" dirty="0"/>
+              <a:t>We did Case Study 1 tonight</a:t>
+            </a:r>
+          </a:p>
+          <a:p>
+            <a:pPr lvl="1"/>
+            <a:r>
+              <a:rPr lang="en-US" dirty="0"/>
+              <a:t>There are currently 16 case studies that explore actuarial data science topics and techniques</a:t>
+            </a:r>
+          </a:p>
+          <a:p>
+            <a:pPr lvl="1"/>
+            <a:r>
+              <a:rPr lang="en-US" dirty="0"/>
+              <a:t>There is also a fantastic Data Sets log that can help you find datasets for your own projects</a:t>
+            </a:r>
+          </a:p>
+        </p:txBody>
+      </p:sp>
+    </p:spTree>
+    <p:extLst>
+      <p:ext uri="{BB962C8B-B14F-4D97-AF65-F5344CB8AC3E}">
+        <p14:creationId xmlns:p14="http://schemas.microsoft.com/office/powerpoint/2010/main" val="2436515003"/>
       </p:ext>
     </p:extLst>
   </p:cSld>

</xml_diff>